<commit_message>
Apply Paisa Vasool LY context to Reliance analysis across deck
LY data finding:
- Jul-25: national conv 88.8%; Reliance offtake ₹3.04 Cr
- Aug-25: national conv 112.6% (+10.8% MoM); Reliance offtake ₹4.45 Cr (+46.4% MoM)
- Confirms Reliance Paisa Vasool mid-Aug pipeline draw-down pattern

PPT changes (landscape slides 4, 7, 9, 16, 18; portrait slides 2, 3, 4):
- Slide 4: EVIDENCE + ACTION updated — validate Reliance Aug offtake by 05-Aug before EAN intervention
- Slide 7 (North): soften "execution failure" — conditional on Aug Paisa Vasool outcome
- Slide 9 (East): moratorium stands but Reliance EAN fix gated on 05-Aug offtake read
- Slide 16 (Chain): split DMart (act now) vs Reliance (validate Aug first)
- Slide 18 (90-day plan): Paisa Vasool checkpoint added as first action before full remediation

Co-Authored-By: Claude Sonnet 4.6 <noreply@anthropic.com>
Claude-Session: https://claude.ai/code/session_01YVLMbr9uhJkpz1MR3Dx7Jp
</commit_message>
<xml_diff>
--- a/MT_Jul26_Honasa_Portrait.pptx
+++ b/MT_Jul26_Honasa_Portrait.pptx
@@ -2574,7 +2574,7 @@
                 <a:ea typeface="Calibri" pitchFamily="34" charset="-122"/>
                 <a:cs typeface="Calibri" pitchFamily="34" charset="-120"/>
               </a:rPr>
-              <a:t>DECISION:  Do not increase primary loading into North/East until EAN-level exceptions are resolved. Apollo's 99.7% is the execution benchmark. Weekly scoreboard from 22-Aug.</a:t>
+              <a:t>DECISION:  Validate Reliance Aug-26 offtake by 05-Aug — Paisa Vasool event expected to recover pipeline (LY: Reliance offtake +46.4% MoM in Aug-25 vs Jul-25). DMart gap (76.5%) needs intervention now. Weekly scoreboard from 22-Aug.</a:t>
             </a:r>
             <a:endParaRPr lang="en-US" sz="750" dirty="0"/>
           </a:p>
@@ -5500,7 +5500,7 @@
                 <a:ea typeface="Calibri" pitchFamily="34" charset="-122"/>
                 <a:cs typeface="Calibri" pitchFamily="34" charset="-120"/>
               </a:rPr>
-              <a:t>North: weekly EAN-level gap closure in Reliance + DMart. Apollo 98.3% is the playbook.</a:t>
+              <a:t>North: validate Reliance Aug offtake first (Paisa Vasool — LY +46.4% MoM). DMart EAN gap closure weekly regardless.</a:t>
             </a:r>
             <a:endParaRPr lang="en-US" sz="850" dirty="0"/>
           </a:p>
@@ -5521,7 +5521,7 @@
                 <a:ea typeface="Calibri" pitchFamily="34" charset="-122"/>
                 <a:cs typeface="Calibri" pitchFamily="34" charset="-120"/>
               </a:rPr>
-              <a:t>East: non-Hero SKU loading moratorium until Aug offtake confirmed. Reliance East 52.9% is the core problem.</a:t>
+              <a:t>East: moratorium holds; check Reliance offtake 05-Aug — if Paisa Vasool converts pipeline, EAN fix may be smaller; if not, full Reliance East exception list by 10-Aug.</a:t>
             </a:r>
             <a:endParaRPr lang="en-US" sz="850" dirty="0"/>
           </a:p>
@@ -6370,7 +6370,7 @@
                 <a:ea typeface="Calibri" pitchFamily="34" charset="-122"/>
                 <a:cs typeface="Calibri" pitchFamily="34" charset="-120"/>
               </a:rPr>
-              <a:t>Apollo 99.7% conversion in the same assortment window confirms demand is present — DMart and Reliance gaps are execution deficits.</a:t>
+              <a:t>Apollo 99.7% confirms demand is present. Reliance gap (51.4%) partly reflects Paisa Vasool pipeline build — LY Reliance offtake rose +46.4% in Aug-25 vs Jul-25. Validate Aug-26 Reliance offtake before declaring full execution deficit.</a:t>
             </a:r>
             <a:endParaRPr lang="en-US" sz="850" dirty="0"/>
           </a:p>

</xml_diff>